<commit_message>
PowerPoint writer: add clrMapOvr to notes slides
Notes slides were written with p:cSld as their only child. The schema
makes p:clrMapOvr optional, but Keynote refuses to import a file with
speaker notes unless it is present ("The file format is invalid").
PowerPoint-authored notes slides contain it, so emit
<p:clrMapOvr><a:masterClrMapping/></p:clrMapOvr> after p:cSld, which
is the order CT_NotesSlide requires.

The golden pptx files that contain notes slides are updated; only the
notesSlide XML parts differ from the previous versions.

Closes #11935.

Signed-off-by: Gaurav Jadhav <gaurav.vjadhav01@gmail.com>
</commit_message>
<xml_diff>
--- a/test/pptx/reference-no-slides/with-notes/output.pptx
+++ b/test/pptx/reference-no-slides/with-notes/output.pptx
@@ -556,6 +556,9 @@
       </p:sp>
     </p:spTree>
   </p:cSld>
+  <p:clrMapOvr>
+    <a:masterClrMapping/>
+  </p:clrMapOvr>
 </p:notes>
 </file>
 
@@ -638,6 +641,9 @@
       </p:sp>
     </p:spTree>
   </p:cSld>
+  <p:clrMapOvr>
+    <a:masterClrMapping/>
+  </p:clrMapOvr>
 </p:notes>
 </file>
 

</xml_diff>

<commit_message>
PowerPoint writer: add clrMapOvr to notes slides (#11960)
Notes slides were written with `p:cSld` as their only child. The schema
makes `p:clrMapOvr` optional, but Keynote refuses to import a file with
speaker notes unless it is present ("The file format is invalid").
PowerPoint-authored notes slides contain it, so emit
`<p:clrMapOvr><a:masterClrMapping/></p:clrMapOvr>` after
`p:cSld`, which is the order `CT_NotesSlide` requires.

The golden pptx files that contain notes slides are updated; only the
notesSlide XML parts differ from the previous versions.

Closes #11935.

Signed-off-by: Gaurav Jadhav <gaurav.vjadhav01@gmail.com>
</commit_message>
<xml_diff>
--- a/test/pptx/reference-no-slides/with-notes/output.pptx
+++ b/test/pptx/reference-no-slides/with-notes/output.pptx
@@ -556,6 +556,9 @@
       </p:sp>
     </p:spTree>
   </p:cSld>
+  <p:clrMapOvr>
+    <a:masterClrMapping/>
+  </p:clrMapOvr>
 </p:notes>
 </file>
 
@@ -638,6 +641,9 @@
       </p:sp>
     </p:spTree>
   </p:cSld>
+  <p:clrMapOvr>
+    <a:masterClrMapping/>
+  </p:clrMapOvr>
 </p:notes>
 </file>
 

</xml_diff>